<commit_message>
Rev 1: Update DBD and PPT for new data pipeline
- Section 9.4: Document refresh_all.sh (5x daily) and daily_export.sh (pre-market)
- Section 12.2: Dashboard shows planned actions only, signals page is source of truth
- Section 12.3: Data files with refresh frequencies, market.json merge-on-write note
- PPT: Updated schedule slide, dashboard slide, rebuild slide for new pipeline

Co-Authored-By: Claude Opus 4.6 <noreply@anthropic.com>
</commit_message>
<xml_diff>
--- a/BigClaw_ShowAndTell.pptx
+++ b/BigClaw_ShowAndTell.pptx
@@ -6511,7 +6511,7 @@
               </a:defRPr>
             </a:pPr>
             <a:r>
-              <a:t>8:55 AM</a:t>
+              <a:t>7:30 AM</a:t>
             </a:r>
           </a:p>
         </p:txBody>
@@ -6590,7 +6590,7 @@
               </a:defRPr>
             </a:pPr>
             <a:r>
-              <a:t>Morning data gather (flat file)</a:t>
+              <a:t>Daily export: sectors, calendar, trades, analysis, charts</a:t>
             </a:r>
           </a:p>
         </p:txBody>
@@ -6626,7 +6626,7 @@
               </a:defRPr>
             </a:pPr>
             <a:r>
-              <a:t>9:00 AM</a:t>
+              <a:t>8:55 AM</a:t>
             </a:r>
           </a:p>
         </p:txBody>
@@ -6705,7 +6705,7 @@
               </a:defRPr>
             </a:pPr>
             <a:r>
-              <a:t>Morning market analysis (Slack)</a:t>
+              <a:t>Morning data gather (flat file)</a:t>
             </a:r>
           </a:p>
         </p:txBody>
@@ -6741,7 +6741,7 @@
               </a:defRPr>
             </a:pPr>
             <a:r>
-              <a:t>Every 2 hrs</a:t>
+              <a:t>9:00 AM</a:t>
             </a:r>
           </a:p>
         </p:txBody>
@@ -6761,7 +6761,7 @@
             <a:avLst/>
           </a:prstGeom>
           <a:solidFill>
-            <a:srgbClr val="8B95A8"/>
+            <a:srgbClr val="3B82F6"/>
           </a:solidFill>
           <a:ln>
             <a:noFill/>
@@ -6820,7 +6820,7 @@
               </a:defRPr>
             </a:pPr>
             <a:r>
-              <a:t>Price refresh + stop ratchet + dashboard</a:t>
+              <a:t>Morning market analysis (Slack)</a:t>
             </a:r>
           </a:p>
         </p:txBody>
@@ -6856,7 +6856,7 @@
               </a:defRPr>
             </a:pPr>
             <a:r>
-              <a:t>Every 2 hrs</a:t>
+              <a:t>5x daily</a:t>
             </a:r>
           </a:p>
         </p:txBody>
@@ -6876,7 +6876,7 @@
             <a:avLst/>
           </a:prstGeom>
           <a:solidFill>
-            <a:srgbClr val="F0B90B"/>
+            <a:srgbClr val="00C48C"/>
           </a:solidFill>
           <a:ln>
             <a:noFill/>
@@ -6935,7 +6935,7 @@
               </a:defRPr>
             </a:pPr>
             <a:r>
-              <a:t>Options intelligence (max pain, IV rank, dark pool)</a:t>
+              <a:t>Signals + prices + macro + charts refresh (pure Python)</a:t>
             </a:r>
           </a:p>
         </p:txBody>
@@ -7050,7 +7050,7 @@
               </a:defRPr>
             </a:pPr>
             <a:r>
-              <a:t>Trailing stop monitor (zero LLM)</a:t>
+              <a:t>Trailing stop monitor (zero LLM cost)</a:t>
             </a:r>
           </a:p>
         </p:txBody>
@@ -7395,7 +7395,7 @@
               </a:defRPr>
             </a:pPr>
             <a:r>
-              <a:t>Portfolio performance report</a:t>
+              <a:t>Portfolio performance report + final refresh</a:t>
             </a:r>
           </a:p>
         </p:txBody>
@@ -8549,7 +8549,7 @@
               </a:defRPr>
             </a:pPr>
             <a:r>
-              <a:t>Home / Dashboard</a:t>
+              <a:t>Dashboard</a:t>
             </a:r>
           </a:p>
         </p:txBody>
@@ -8604,11 +8604,11 @@
               </a:defRPr>
             </a:pPr>
             <a:r>
-              <a:t>Overall performance, 7 portfolio cards,</a:t>
+              <a:t>Planned actions (sells + strong buys only),</a:t>
             </a:r>
             <a:br/>
             <a:r>
-              <a:t>sector heatmap, earnings calendar</a:t>
+              <a:t>7 portfolio cards, sector heatmap, recent trades</a:t>
             </a:r>
           </a:p>
         </p:txBody>
@@ -8657,13 +8657,13 @@
             <a:pPr algn="ctr">
               <a:defRPr sz="1200" b="1">
                 <a:solidFill>
-                  <a:srgbClr val="00C48C"/>
-                </a:solidFill>
-                <a:latin typeface="Calibri"/>
-              </a:defRPr>
-            </a:pPr>
-            <a:r>
-              <a:t>Portfolio Detail</a:t>
+                  <a:srgbClr val="F0B90B"/>
+                </a:solidFill>
+                <a:latin typeface="Calibri"/>
+              </a:defRPr>
+            </a:pPr>
+            <a:r>
+              <a:t>Signals (source of truth)</a:t>
             </a:r>
           </a:p>
         </p:txBody>
@@ -8718,11 +8718,11 @@
               </a:defRPr>
             </a:pPr>
             <a:r>
-              <a:t>Sortable holdings table, P&amp;L per position,</a:t>
+              <a:t>All tickers scored: action, watch, hold.</a:t>
             </a:r>
             <a:br/>
             <a:r>
-              <a:t>metrics cards, click any ticker to drill down</a:t>
+              <a:t>Macro, sentiment, bonds, alerts &amp; warnings</a:t>
             </a:r>
           </a:p>
         </p:txBody>
@@ -8771,13 +8771,13 @@
             <a:pPr algn="ctr">
               <a:defRPr sz="1200" b="1">
                 <a:solidFill>
-                  <a:srgbClr val="F0B90B"/>
-                </a:solidFill>
-                <a:latin typeface="Calibri"/>
-              </a:defRPr>
-            </a:pPr>
-            <a:r>
-              <a:t>Signals</a:t>
+                  <a:srgbClr val="00C48C"/>
+                </a:solidFill>
+                <a:latin typeface="Calibri"/>
+              </a:defRPr>
+            </a:pPr>
+            <a:r>
+              <a:t>Portfolio Detail</a:t>
             </a:r>
           </a:p>
         </p:txBody>
@@ -8832,11 +8832,11 @@
               </a:defRPr>
             </a:pPr>
             <a:r>
-              <a:t>All ~105 tickers scored with buy/sell/hold,</a:t>
+              <a:t>Sortable holdings table, P&amp;L per position,</a:t>
             </a:r>
             <a:br/>
             <a:r>
-              <a:t>expandable reasoning, macro + bond cards</a:t>
+              <a:t>metrics cards, click any ticker to drill down</a:t>
             </a:r>
           </a:p>
         </p:txBody>
@@ -9041,11 +9041,11 @@
               </a:defRPr>
             </a:pPr>
             <a:r>
-              <a:t>price_refresh.py</a:t>
+              <a:t>refresh_all.sh</a:t>
             </a:r>
             <a:br/>
             <a:r>
-              <a:t>(every 2 hrs)</a:t>
+              <a:t>(5x daily)</a:t>
             </a:r>
           </a:p>
         </p:txBody>
@@ -9285,7 +9285,7 @@
               </a:defRPr>
             </a:pPr>
             <a:r>
-              <a:t>Also available on the dashboard:</a:t>
+              <a:t>Dashboard vs Signals page:</a:t>
             </a:r>
           </a:p>
         </p:txBody>
@@ -9333,7 +9333,7 @@
                 </a:solidFill>
                 <a:latin typeface="Calibri"/>
               </a:rPr>
-              <a:t>Recent </a:t>
+              <a:t>Dashboard = </a:t>
             </a:r>
             <a:r>
               <a:rPr sz="1200" b="1">
@@ -9342,7 +9342,7 @@
                 </a:solidFill>
                 <a:latin typeface="Calibri"/>
               </a:rPr>
-              <a:t>trades</a:t>
+              <a:t>planned actions only</a:t>
             </a:r>
             <a:r>
               <a:rPr sz="1200" b="0">
@@ -9351,7 +9351,7 @@
                 </a:solidFill>
                 <a:latin typeface="Calibri"/>
               </a:rPr>
-              <a:t> and rebalance history</a:t>
+              <a:t> (sells + strong buys)</a:t>
             </a:r>
           </a:p>
           <a:p>
@@ -9370,13 +9370,22 @@
               <a:t>  &gt;  </a:t>
             </a:r>
             <a:r>
+              <a:rPr sz="1200" b="0">
+                <a:solidFill>
+                  <a:srgbClr val="E8EDF5"/>
+                </a:solidFill>
+                <a:latin typeface="Calibri"/>
+              </a:rPr>
+              <a:t>Signals page = </a:t>
+            </a:r>
+            <a:r>
               <a:rPr sz="1200" b="1">
                 <a:solidFill>
                   <a:srgbClr val="E8EDF5"/>
                 </a:solidFill>
                 <a:latin typeface="Calibri"/>
               </a:rPr>
-              <a:t>Earnings calendar</a:t>
+              <a:t>single source of truth</a:t>
             </a:r>
             <a:r>
               <a:rPr sz="1200" b="0">
@@ -9385,7 +9394,7 @@
                 </a:solidFill>
                 <a:latin typeface="Calibri"/>
               </a:rPr>
-              <a:t> with countdown</a:t>
+              <a:t> for all scores</a:t>
             </a:r>
           </a:p>
           <a:p>
@@ -9404,22 +9413,22 @@
               <a:t>  &gt;  </a:t>
             </a:r>
             <a:r>
+              <a:rPr sz="1200" b="0">
+                <a:solidFill>
+                  <a:srgbClr val="E8EDF5"/>
+                </a:solidFill>
+                <a:latin typeface="Calibri"/>
+              </a:rPr>
+              <a:t>Macro, sentiment, bonds, alerts live on </a:t>
+            </a:r>
+            <a:r>
               <a:rPr sz="1200" b="1">
                 <a:solidFill>
                   <a:srgbClr val="E8EDF5"/>
                 </a:solidFill>
                 <a:latin typeface="Calibri"/>
               </a:rPr>
-              <a:t>Sector rotation</a:t>
-            </a:r>
-            <a:r>
-              <a:rPr sz="1200" b="0">
-                <a:solidFill>
-                  <a:srgbClr val="E8EDF5"/>
-                </a:solidFill>
-                <a:latin typeface="Calibri"/>
-              </a:rPr>
-              <a:t> heatmap (1-month performance)</a:t>
+              <a:t>signals page</a:t>
             </a:r>
           </a:p>
           <a:p>
@@ -9444,7 +9453,7 @@
                 </a:solidFill>
                 <a:latin typeface="Calibri"/>
               </a:rPr>
-              <a:t>Macro overview</a:t>
+              <a:t>Sector rotation</a:t>
             </a:r>
             <a:r>
               <a:rPr sz="1200" b="0">
@@ -9453,7 +9462,7 @@
                 </a:solidFill>
                 <a:latin typeface="Calibri"/>
               </a:rPr>
-              <a:t>: Fed Funds, 10Y, VIX, Gold, BTC</a:t>
+              <a:t> heatmap on dashboard (daily refresh)</a:t>
             </a:r>
           </a:p>
           <a:p>
@@ -9472,13 +9481,22 @@
               <a:t>  &gt;  </a:t>
             </a:r>
             <a:r>
+              <a:rPr sz="1200" b="0">
+                <a:solidFill>
+                  <a:srgbClr val="E8EDF5"/>
+                </a:solidFill>
+                <a:latin typeface="Calibri"/>
+              </a:rPr>
+              <a:t>Recent </a:t>
+            </a:r>
+            <a:r>
               <a:rPr sz="1200" b="1">
                 <a:solidFill>
                   <a:srgbClr val="E8EDF5"/>
                 </a:solidFill>
                 <a:latin typeface="Calibri"/>
               </a:rPr>
-              <a:t>Sentiment</a:t>
+              <a:t>trades</a:t>
             </a:r>
             <a:r>
               <a:rPr sz="1200" b="0">
@@ -9487,7 +9505,7 @@
                 </a:solidFill>
                 <a:latin typeface="Calibri"/>
               </a:rPr>
-              <a:t>: CNN Fear &amp; Greed, Michigan Consumer</a:t>
+              <a:t> (last 2 trading days) on dashboard</a:t>
             </a:r>
           </a:p>
           <a:p>
@@ -9512,7 +9530,7 @@
                 </a:solidFill>
                 <a:latin typeface="Calibri"/>
               </a:rPr>
-              <a:t>Bond market</a:t>
+              <a:t>Slack alerts</a:t>
             </a:r>
             <a:r>
               <a:rPr sz="1200" b="0">
@@ -9521,7 +9539,7 @@
                 </a:solidFill>
                 <a:latin typeface="Calibri"/>
               </a:rPr>
-              <a:t> score + yield curve analysis</a:t>
+              <a:t> fire if any refresh fails</a:t>
             </a:r>
           </a:p>
           <a:p>
@@ -9540,13 +9558,22 @@
               <a:t>  &gt;  </a:t>
             </a:r>
             <a:r>
+              <a:rPr sz="1200" b="0">
+                <a:solidFill>
+                  <a:srgbClr val="E8EDF5"/>
+                </a:solidFill>
+                <a:latin typeface="Calibri"/>
+              </a:rPr>
+              <a:t>All refreshes are </a:t>
+            </a:r>
+            <a:r>
               <a:rPr sz="1200" b="1">
                 <a:solidFill>
                   <a:srgbClr val="E8EDF5"/>
                 </a:solidFill>
                 <a:latin typeface="Calibri"/>
               </a:rPr>
-              <a:t>Alerts</a:t>
+              <a:t>pure Python</a:t>
             </a:r>
             <a:r>
               <a:rPr sz="1200" b="0">
@@ -9555,7 +9582,7 @@
                 </a:solidFill>
                 <a:latin typeface="Calibri"/>
               </a:rPr>
-              <a:t>: concentration, earnings, sell signals, VIX &gt; 25</a:t>
+              <a:t> — zero LLM cost</a:t>
             </a:r>
           </a:p>
         </p:txBody>
@@ -13381,7 +13408,7 @@
               </a:defRPr>
             </a:pPr>
             <a:r>
-              <a:t>Copy systemd service files + restore crontab entries</a:t>
+              <a:t>Copy systemd service files + restore crontab (8 scheduled jobs)</a:t>
             </a:r>
           </a:p>
         </p:txBody>

</xml_diff>

<commit_message>
Rev 1: Add supervisory display, swap context, autonomous trader schedule
- DBD: Document autonomous trader crontab (9:30 AM CT), 30-min supervisory window
- DBD: Signals page is supervisory display with holding context and swap recs
- DBD: signals.json now includes portfolio holdings and swap recommendations
- PPT: Updated schedule, dashboard, and signals slides to match

Co-Authored-By: Claude Opus 4.6 <noreply@anthropic.com>
</commit_message>
<xml_diff>
--- a/BigClaw_ShowAndTell.pptx
+++ b/BigClaw_ShowAndTell.pptx
@@ -6761,7 +6761,7 @@
             <a:avLst/>
           </a:prstGeom>
           <a:solidFill>
-            <a:srgbClr val="3B82F6"/>
+            <a:srgbClr val="00C48C"/>
           </a:solidFill>
           <a:ln>
             <a:noFill/>
@@ -6820,7 +6820,7 @@
               </a:defRPr>
             </a:pPr>
             <a:r>
-              <a:t>Morning market analysis (Slack)</a:t>
+              <a:t>Signals refresh -- supervisory window opens</a:t>
             </a:r>
           </a:p>
         </p:txBody>
@@ -6856,7 +6856,7 @@
               </a:defRPr>
             </a:pPr>
             <a:r>
-              <a:t>5x daily</a:t>
+              <a:t>9:30 AM</a:t>
             </a:r>
           </a:p>
         </p:txBody>
@@ -6935,7 +6935,7 @@
               </a:defRPr>
             </a:pPr>
             <a:r>
-              <a:t>Signals + prices + macro + charts refresh (pure Python)</a:t>
+              <a:t>Autonomous trader executes (sells, swaps, buys)</a:t>
             </a:r>
           </a:p>
         </p:txBody>
@@ -6971,7 +6971,7 @@
               </a:defRPr>
             </a:pPr>
             <a:r>
-              <a:t>Every 15 min</a:t>
+              <a:t>5x daily</a:t>
             </a:r>
           </a:p>
         </p:txBody>
@@ -6985,6 +6985,121 @@
         <p:spPr>
           <a:xfrm>
             <a:off x="2286000" y="4142232"/>
+            <a:ext cx="146304" cy="146304"/>
+          </a:xfrm>
+          <a:prstGeom prst="ellipse">
+            <a:avLst/>
+          </a:prstGeom>
+          <a:solidFill>
+            <a:srgbClr val="8B95A8"/>
+          </a:solidFill>
+          <a:ln>
+            <a:noFill/>
+          </a:ln>
+        </p:spPr>
+        <p:style>
+          <a:lnRef idx="1">
+            <a:schemeClr val="accent1"/>
+          </a:lnRef>
+          <a:fillRef idx="3">
+            <a:schemeClr val="accent1"/>
+          </a:fillRef>
+          <a:effectRef idx="2">
+            <a:schemeClr val="accent1"/>
+          </a:effectRef>
+          <a:fontRef idx="minor">
+            <a:schemeClr val="lt1"/>
+          </a:fontRef>
+        </p:style>
+        <p:txBody>
+          <a:bodyPr rtlCol="0" anchor="ctr"/>
+          <a:lstStyle/>
+          <a:p>
+            <a:pPr algn="ctr"/>
+          </a:p>
+        </p:txBody>
+      </p:sp>
+      <p:sp>
+        <p:nvSpPr>
+          <p:cNvPr id="24" name="TextBox 23"/>
+          <p:cNvSpPr txBox="1"/>
+          <p:nvPr/>
+        </p:nvSpPr>
+        <p:spPr>
+          <a:xfrm>
+            <a:off x="2560320" y="4069080"/>
+            <a:ext cx="4572000" cy="411480"/>
+          </a:xfrm>
+          <a:prstGeom prst="rect">
+            <a:avLst/>
+          </a:prstGeom>
+          <a:noFill/>
+        </p:spPr>
+        <p:txBody>
+          <a:bodyPr wrap="square">
+            <a:spAutoFit/>
+          </a:bodyPr>
+          <a:lstStyle/>
+          <a:p>
+            <a:pPr algn="l">
+              <a:defRPr sz="1200" b="0" i="0">
+                <a:solidFill>
+                  <a:srgbClr val="E8EDF5"/>
+                </a:solidFill>
+                <a:latin typeface="Calibri"/>
+              </a:defRPr>
+            </a:pPr>
+            <a:r>
+              <a:t>Signals + prices + macro + charts (pure Python)</a:t>
+            </a:r>
+          </a:p>
+        </p:txBody>
+      </p:sp>
+      <p:sp>
+        <p:nvSpPr>
+          <p:cNvPr id="25" name="TextBox 24"/>
+          <p:cNvSpPr txBox="1"/>
+          <p:nvPr/>
+        </p:nvSpPr>
+        <p:spPr>
+          <a:xfrm>
+            <a:off x="731520" y="4572000"/>
+            <a:ext cx="1463040" cy="411480"/>
+          </a:xfrm>
+          <a:prstGeom prst="rect">
+            <a:avLst/>
+          </a:prstGeom>
+          <a:noFill/>
+        </p:spPr>
+        <p:txBody>
+          <a:bodyPr wrap="square">
+            <a:spAutoFit/>
+          </a:bodyPr>
+          <a:lstStyle/>
+          <a:p>
+            <a:pPr algn="l">
+              <a:defRPr sz="1100" b="1" i="0">
+                <a:solidFill>
+                  <a:srgbClr val="F0B90B"/>
+                </a:solidFill>
+                <a:latin typeface="Calibri"/>
+              </a:defRPr>
+            </a:pPr>
+            <a:r>
+              <a:t>Every 15 min</a:t>
+            </a:r>
+          </a:p>
+        </p:txBody>
+      </p:sp>
+      <p:sp>
+        <p:nvSpPr>
+          <p:cNvPr id="26" name="Oval 25"/>
+          <p:cNvSpPr/>
+          <p:nvPr/>
+        </p:nvSpPr>
+        <p:spPr>
+          <a:xfrm>
+            <a:off x="2286000" y="4645152"/>
             <a:ext cx="146304" cy="146304"/>
           </a:xfrm>
           <a:prstGeom prst="ellipse">
@@ -7021,13 +7136,13 @@
       </p:sp>
       <p:sp>
         <p:nvSpPr>
-          <p:cNvPr id="24" name="TextBox 23"/>
+          <p:cNvPr id="27" name="TextBox 26"/>
           <p:cNvSpPr txBox="1"/>
           <p:nvPr/>
         </p:nvSpPr>
         <p:spPr>
           <a:xfrm>
-            <a:off x="2560320" y="4069080"/>
+            <a:off x="2560320" y="4572000"/>
             <a:ext cx="4572000" cy="411480"/>
           </a:xfrm>
           <a:prstGeom prst="rect">
@@ -7051,121 +7166,6 @@
             </a:pPr>
             <a:r>
               <a:t>Trailing stop monitor (zero LLM cost)</a:t>
-            </a:r>
-          </a:p>
-        </p:txBody>
-      </p:sp>
-      <p:sp>
-        <p:nvSpPr>
-          <p:cNvPr id="25" name="TextBox 24"/>
-          <p:cNvSpPr txBox="1"/>
-          <p:nvPr/>
-        </p:nvSpPr>
-        <p:spPr>
-          <a:xfrm>
-            <a:off x="731520" y="4572000"/>
-            <a:ext cx="1463040" cy="411480"/>
-          </a:xfrm>
-          <a:prstGeom prst="rect">
-            <a:avLst/>
-          </a:prstGeom>
-          <a:noFill/>
-        </p:spPr>
-        <p:txBody>
-          <a:bodyPr wrap="square">
-            <a:spAutoFit/>
-          </a:bodyPr>
-          <a:lstStyle/>
-          <a:p>
-            <a:pPr algn="l">
-              <a:defRPr sz="1100" b="1" i="0">
-                <a:solidFill>
-                  <a:srgbClr val="F0B90B"/>
-                </a:solidFill>
-                <a:latin typeface="Calibri"/>
-              </a:defRPr>
-            </a:pPr>
-            <a:r>
-              <a:t>10:30 AM</a:t>
-            </a:r>
-          </a:p>
-        </p:txBody>
-      </p:sp>
-      <p:sp>
-        <p:nvSpPr>
-          <p:cNvPr id="26" name="Oval 25"/>
-          <p:cNvSpPr/>
-          <p:nvPr/>
-        </p:nvSpPr>
-        <p:spPr>
-          <a:xfrm>
-            <a:off x="2286000" y="4645152"/>
-            <a:ext cx="146304" cy="146304"/>
-          </a:xfrm>
-          <a:prstGeom prst="ellipse">
-            <a:avLst/>
-          </a:prstGeom>
-          <a:solidFill>
-            <a:srgbClr val="00C48C"/>
-          </a:solidFill>
-          <a:ln>
-            <a:noFill/>
-          </a:ln>
-        </p:spPr>
-        <p:style>
-          <a:lnRef idx="1">
-            <a:schemeClr val="accent1"/>
-          </a:lnRef>
-          <a:fillRef idx="3">
-            <a:schemeClr val="accent1"/>
-          </a:fillRef>
-          <a:effectRef idx="2">
-            <a:schemeClr val="accent1"/>
-          </a:effectRef>
-          <a:fontRef idx="minor">
-            <a:schemeClr val="lt1"/>
-          </a:fontRef>
-        </p:style>
-        <p:txBody>
-          <a:bodyPr rtlCol="0" anchor="ctr"/>
-          <a:lstStyle/>
-          <a:p>
-            <a:pPr algn="ctr"/>
-          </a:p>
-        </p:txBody>
-      </p:sp>
-      <p:sp>
-        <p:nvSpPr>
-          <p:cNvPr id="27" name="TextBox 26"/>
-          <p:cNvSpPr txBox="1"/>
-          <p:nvPr/>
-        </p:nvSpPr>
-        <p:spPr>
-          <a:xfrm>
-            <a:off x="2560320" y="4572000"/>
-            <a:ext cx="4572000" cy="411480"/>
-          </a:xfrm>
-          <a:prstGeom prst="rect">
-            <a:avLst/>
-          </a:prstGeom>
-          <a:noFill/>
-        </p:spPr>
-        <p:txBody>
-          <a:bodyPr wrap="square">
-            <a:spAutoFit/>
-          </a:bodyPr>
-          <a:lstStyle/>
-          <a:p>
-            <a:pPr algn="l">
-              <a:defRPr sz="1200" b="0" i="0">
-                <a:solidFill>
-                  <a:srgbClr val="E8EDF5"/>
-                </a:solidFill>
-                <a:latin typeface="Calibri"/>
-              </a:defRPr>
-            </a:pPr>
-            <a:r>
-              <a:t>Full autonomous trading</a:t>
             </a:r>
           </a:p>
         </p:txBody>
@@ -7395,7 +7395,7 @@
               </a:defRPr>
             </a:pPr>
             <a:r>
-              <a:t>Portfolio performance report + final refresh</a:t>
+              <a:t>Portfolio report + final refresh</a:t>
             </a:r>
           </a:p>
         </p:txBody>
@@ -8663,7 +8663,7 @@
               </a:defRPr>
             </a:pPr>
             <a:r>
-              <a:t>Signals (source of truth)</a:t>
+              <a:t>Signals (supervisory display)</a:t>
             </a:r>
           </a:p>
         </p:txBody>
@@ -8718,11 +8718,11 @@
               </a:defRPr>
             </a:pPr>
             <a:r>
-              <a:t>All tickers scored: action, watch, hold.</a:t>
+              <a:t>All tickers with holding context, swap recs,</a:t>
             </a:r>
             <a:br/>
             <a:r>
-              <a:t>Macro, sentiment, bonds, alerts &amp; warnings</a:t>
+              <a:t>score differentials. Macro, bonds, alerts</a:t>
             </a:r>
           </a:p>
         </p:txBody>
@@ -9376,7 +9376,7 @@
                 </a:solidFill>
                 <a:latin typeface="Calibri"/>
               </a:rPr>
-              <a:t>Signals page = </a:t>
+              <a:t>Signals = </a:t>
             </a:r>
             <a:r>
               <a:rPr sz="1200" b="1">
@@ -9385,7 +9385,7 @@
                 </a:solidFill>
                 <a:latin typeface="Calibri"/>
               </a:rPr>
-              <a:t>single source of truth</a:t>
+              <a:t>supervisory display</a:t>
             </a:r>
             <a:r>
               <a:rPr sz="1200" b="0">
@@ -9394,7 +9394,7 @@
                 </a:solidFill>
                 <a:latin typeface="Calibri"/>
               </a:rPr>
-              <a:t> for all scores</a:t>
+              <a:t> (like Tesla FSD Supervised)</a:t>
             </a:r>
           </a:p>
           <a:p>
@@ -9419,7 +9419,7 @@
                 </a:solidFill>
                 <a:latin typeface="Calibri"/>
               </a:rPr>
-              <a:t>Macro, sentiment, bonds, alerts live on </a:t>
+              <a:t>Each signal shows </a:t>
             </a:r>
             <a:r>
               <a:rPr sz="1200" b="1">
@@ -9428,7 +9428,16 @@
                 </a:solidFill>
                 <a:latin typeface="Calibri"/>
               </a:rPr>
-              <a:t>signals page</a:t>
+              <a:t>portfolio tags</a:t>
+            </a:r>
+            <a:r>
+              <a:rPr sz="1200" b="0">
+                <a:solidFill>
+                  <a:srgbClr val="E8EDF5"/>
+                </a:solidFill>
+                <a:latin typeface="Calibri"/>
+              </a:rPr>
+              <a:t>, position %, capacity status</a:t>
             </a:r>
           </a:p>
           <a:p>
@@ -9453,7 +9462,7 @@
                 </a:solidFill>
                 <a:latin typeface="Calibri"/>
               </a:rPr>
-              <a:t>Sector rotation</a:t>
+              <a:t>Swap recommendations</a:t>
             </a:r>
             <a:r>
               <a:rPr sz="1200" b="0">
@@ -9462,7 +9471,7 @@
                 </a:solidFill>
                 <a:latin typeface="Calibri"/>
               </a:rPr>
-              <a:t> heatmap on dashboard (daily refresh)</a:t>
+              <a:t> with score differentials shown inline</a:t>
             </a:r>
           </a:p>
           <a:p>
@@ -9487,7 +9496,7 @@
                 </a:solidFill>
                 <a:latin typeface="Calibri"/>
               </a:rPr>
-              <a:t>Recent </a:t>
+              <a:t>9:00 AM refresh -&gt; </a:t>
             </a:r>
             <a:r>
               <a:rPr sz="1200" b="1">
@@ -9496,7 +9505,7 @@
                 </a:solidFill>
                 <a:latin typeface="Calibri"/>
               </a:rPr>
-              <a:t>trades</a:t>
+              <a:t>30-min review window</a:t>
             </a:r>
             <a:r>
               <a:rPr sz="1200" b="0">
@@ -9505,7 +9514,7 @@
                 </a:solidFill>
                 <a:latin typeface="Calibri"/>
               </a:rPr>
-              <a:t> (last 2 trading days) on dashboard</a:t>
+              <a:t> -&gt; 10:30 AM trades</a:t>
             </a:r>
           </a:p>
           <a:p>

</xml_diff>

<commit_message>
Ship four-sleeve live book, Commando radar/doctrine, and Alpaca guard harden.
Active sleeves: Innovation, Momentum, AI Defense, LLM-Commando. Event radar with
price_is_news half-exits; cold-trader REAL>THEATER / no-chase doctrine; active-only
pre/post Alpaca sync with self-heal. Docs: DESIGN_BASIS + ShowAndTell updated.
OpenRouter/Grok Judge remains experimental (not production).
</commit_message>
<xml_diff>
--- a/BigClaw_ShowAndTell.pptx
+++ b/BigClaw_ShowAndTell.pptx
@@ -33,6 +33,10 @@
     <p:sldId id="272" r:id="rId23"/>
     <p:sldId id="273" r:id="rId24"/>
     <p:sldId id="274" r:id="rId25"/>
+    <p:sldId id="284" r:id="rId35"/>
+    <p:sldId id="285" r:id="rId36"/>
+    <p:sldId id="286" r:id="rId37"/>
+    <p:sldId id="287" r:id="rId38"/>
   </p:sldIdLst>
   <p:sldSz cx="12191695" cy="6858000" type="screen4x3"/>
   <p:notesSz cx="6858000" cy="9144000"/>
@@ -3372,7 +3376,7 @@
               </a:defRPr>
             </a:pPr>
             <a:r>
-              <a:t>Curtis Biggs  |  March 2026</a:t>
+              <a:t>Curtis Biggs  |  July 2026</a:t>
             </a:r>
           </a:p>
         </p:txBody>
@@ -3408,7 +3412,7 @@
               </a:defRPr>
             </a:pPr>
             <a:r>
-              <a:t>DBD-AI-001 Rev. 1</a:t>
+              <a:t>DBD-AI-001 · updated July 22 2026</a:t>
             </a:r>
           </a:p>
         </p:txBody>
@@ -3460,7 +3464,7 @@
                   <a:srgbClr val="F0B90B"/>
                 </a:solidFill>
               </a:rPr>
-              <a:t>The 9th Portfolio — LLM-Comando (Stock Picker)</a:t>
+              <a:t>The 9th Portfolio — LLM-Commando (Stock Picker + Event Radar)</a:t>
             </a:r>
           </a:p>
         </p:txBody>
@@ -3486,7 +3490,7 @@
                   <a:srgbClr val="E8EDF5"/>
                 </a:solidFill>
               </a:rPr>
-              <a:t>Added June 10 2026 as a parallel experiment to LLM-ETF Focus — same dialectic, individual-stock mandate.</a:t>
+              <a:t>LIVE single-stock book: 3-agent dialectic (Sonnet Bull/Bear, Opus Judge) at 09:00 / 11:30 / 14:30 CT + event radar every 2 min RTH. Strict no-ETF. Cold-trader doctrine: real prints &gt; tariff threats; no day-2 chase.</a:t>
             </a:r>
           </a:p>
           <a:p>
@@ -3497,7 +3501,7 @@
                   <a:srgbClr val="E8EDF5"/>
                 </a:solidFill>
               </a:rPr>
-              <a:t>Same 3-Sonnet dialectic (Bull / Bear / Judge), same watcher + reconciler architecture</a:t>
+              <a:t>LIVE single-stock book: 3-agent dialectic (Sonnet Bull/Bear, Opus Judge) at 09:00 / 11:30 / 14:30 CT + event radar every 2 min RTH. Strict no-ETF. Cold-trader doctrine: real prints &gt; tariff threats; no day-2 chase.</a:t>
             </a:r>
           </a:p>
           <a:p>
@@ -3563,7 +3567,7 @@
                   <a:srgbClr val="E8EDF5"/>
                 </a:solidFill>
               </a:rPr>
-              <a:t>Dry-run (June 10): picked AMAT (Cantor + UBS PT raises) and APA (Iran/oil thesis) — no ETFs</a:t>
+              <a:t>LIVE single-stock book: 3-agent dialectic (Sonnet Bull/Bear, Opus Judge) at 09:00 / 11:30 / 14:30 CT + event radar every 2 min RTH. Strict no-ETF. Cold-trader doctrine: real prints &gt; tariff threats; no day-2 chase.</a:t>
             </a:r>
           </a:p>
           <a:p>
@@ -3637,7 +3641,7 @@
                   <a:srgbClr val="F0B90B"/>
                 </a:solidFill>
               </a:rPr>
-              <a:t>Comando Dialectic Upgrade (June 15): The Judge Finds the Gap</a:t>
+              <a:t>Commando Dialectic Upgrade (June 15): The Judge Finds the Gap</a:t>
             </a:r>
           </a:p>
         </p:txBody>
@@ -3664,7 +3668,7 @@
                   <a:srgbClr val="E8EDF5"/>
                 </a:solidFill>
               </a:rPr>
-              <a:t>Live lesson from the experiment: on June 15 Comando bought AAL on a day-old catalyst (oil drop + signed MOU) already baked into a stock that had already run. It got in late and faded. Fast iteration means we fix as we go.</a:t>
+              <a:t>Live lesson from the experiment: on June 15 Commando bought AAL on a day-old catalyst (oil drop + signed MOU) already baked into a stock that had already run. It got in late and faded. Fast iteration means we fix as we go.</a:t>
             </a:r>
           </a:p>
           <a:p>
@@ -3719,7 +3723,7 @@
                   <a:srgbClr val="E8EDF5"/>
                 </a:solidFill>
               </a:rPr>
-              <a:t>Reusable beyond Comando: gap-first synthesis is a design rule for any LLM decision system built on this platform.</a:t>
+              <a:t>Reusable beyond Commando: gap-first synthesis is a design rule for any LLM decision system built on this platform.</a:t>
             </a:r>
           </a:p>
           <a:p>
@@ -3809,7 +3813,7 @@
                   <a:srgbClr val="E8EDF5"/>
                 </a:solidFill>
               </a:rPr>
-              <a:t>Theme of the batch: give the two LLM portfolios a forward, regime-aware read of the market, let Comando be active in a bull tape, and let CONVICTION - not the clock - govern exits. Five changes shipped June 16-18.</a:t>
+              <a:t>Theme of the batch: give the two LLM portfolios a forward, regime-aware read of the market, let Commando be active in a bull tape, and let CONVICTION - not the clock - govern exits. Five changes shipped June 16-18.</a:t>
             </a:r>
           </a:p>
           <a:p>
@@ -3820,7 +3824,7 @@
                   <a:srgbClr val="E8EDF5"/>
                 </a:solidFill>
               </a:rPr>
-              <a:t>Macro-regime cycle pack (Jun 16): both LLM books now read a 'cycle tells' block - VIX level/trend, high-yield vs investment-grade credit, 10y yield, offense/defense (XLY vs XLP), breadth (IWM vs SPY), 3-month rotation leaders. ETF Focus positions sectors months-out (lead the rotation); Comando uses VIX to set aggression.</a:t>
+              <a:t>Macro-regime cycle pack (Jun 16): both LLM books now read a 'cycle tells' block - VIX level/trend, high-yield vs investment-grade credit, 10y yield, offense/defense (XLY vs XLP), breadth (IWM vs SPY), 3-month rotation leaders. ETF Focus positions sectors months-out (lead the rotation); Commando uses VIX to set aggression.</a:t>
             </a:r>
           </a:p>
           <a:p>
@@ -3831,7 +3835,7 @@
                   <a:srgbClr val="E8EDF5"/>
                 </a:solidFill>
               </a:rPr>
-              <a:t>Comando momentum sourcing (Jun 17): pulls the rule engine's ~537 scored names and ranks momentum leaders (1mo+3mo relative strength, proximity to 6-month high) into a MOMENTUM LEADERS block - so Comando trades clean uptrends instead of sitting in cash after gap-analysis rejects priced-in headlines.</a:t>
+              <a:t>Commando momentum sourcing (Jun 17): pulls the rule engine's ~537 scored names and ranks momentum leaders (1mo+3mo relative strength, proximity to 6-month high) into a MOMENTUM LEADERS block - so Commando trades clean uptrends instead of sitting in cash after gap-analysis rejects priced-in headlines.</a:t>
             </a:r>
           </a:p>
           <a:p>
@@ -3853,7 +3857,7 @@
                   <a:srgbClr val="E8EDF5"/>
                 </a:solidFill>
               </a:rPr>
-              <a:t>Conviction-based exit for Comando (Jun 18): replaced the time-based quick-out. Before selling, ask 'would I buy this right now?' - if yes, HOLD; if no, sell and redeploy. Holding time is irrelevant; the trigger is always conviction, never a timer.</a:t>
+              <a:t>Conviction-based exit for Commando (Jun 18): replaced the time-based quick-out. Before selling, ask 'would I buy this right now?' - if yes, HOLD; if no, sell and redeploy. Holding time is irrelevant; the trigger is always conviction, never a timer.</a:t>
             </a:r>
           </a:p>
           <a:p>
@@ -3885,7 +3889,7 @@
                   <a:srgbClr val="E8EDF5"/>
                 </a:solidFill>
               </a:rPr>
-              <a:t>NOTE (June 25 2026): the months-horizon framing for ETF Focus and Comando's momentum sourcing were later REVERTED - see the next slide.</a:t>
+              <a:t>NOTE (June 25 2026): the months-horizon framing for ETF Focus and Commando's momentum sourcing were later REVERTED - see the next slide.</a:t>
             </a:r>
           </a:p>
         </p:txBody>
@@ -3983,7 +3987,7 @@
                   <a:srgbClr val="E8EDF5"/>
                 </a:solidFill>
               </a:rPr>
-              <a:t>Comando -&gt; NEWS-ONLY discovery (removed June-17 momentum sourcing): price momentum with no news behind it is bandwagon-chasing, not a thesis. Every entry must rest on a citable, still-playing-out catalyst; thin news = hold cash, do not manufacture a momentum trade.</a:t>
+              <a:t>Commando -&gt; NEWS-ONLY discovery (removed June-17 momentum sourcing): price momentum with no news behind it is bandwagon-chasing, not a thesis. Every entry must rest on a citable, still-playing-out catalyst; thin news = hold cash, do not manufacture a momentum trade.</a:t>
             </a:r>
           </a:p>
           <a:p>
@@ -4092,7 +4096,7 @@
                   <a:srgbClr val="E8EDF5"/>
                 </a:solidFill>
               </a:rPr>
-              <a:t>Overnight doctrine (Comando Judge): banking a gain is control, finality, loss-prevention; holding overnight is unprotected risk (trailing stops don't run when the market is closed) - so the burden of proof shifts to HOLDING, default is bank into the close.</a:t>
+              <a:t>Overnight doctrine (Commando Judge): banking a gain is control, finality, loss-prevention; holding overnight is unprotected risk (trailing stops don't run when the market is closed) - so the burden of proof shifts to HOLDING, default is bank into the close.</a:t>
             </a:r>
           </a:p>
           <a:p>
@@ -4382,7 +4386,7 @@
                   <a:srgbClr val="E8EDF5"/>
                 </a:solidFill>
               </a:rPr>
-              <a:t>Forward planned-actions list refreshed on the same cadence; LLM Comando/ETF panels published right after each cycle (9:20 / 11:50 / 14:50 CT) so intraday trades appear within minutes, not at the next anchor.</a:t>
+              <a:t>Forward planned-actions list refreshed on the same cadence; LLM Commando/ETF panels published right after each cycle (9:20 / 11:50 / 14:50 CT) so intraday trades appear within minutes, not at the next anchor.</a:t>
             </a:r>
           </a:p>
           <a:p>
@@ -4494,7 +4498,7 @@
                   <a:srgbClr val="E8EDF5"/>
                 </a:solidFill>
               </a:rPr>
-              <a:t>Ran a live A/B: Fable 5 as the executing Comando Judge, with Opus 4.8 shadowing the identical Bull/Bear input (logged, not traded).</a:t>
+              <a:t>Ran a live A/B: Fable 5 as the executing Commando Judge, with Opus 4.8 shadowing the identical Bull/Bear input (logged, not traded).</a:t>
             </a:r>
           </a:p>
           <a:p>
@@ -16855,6 +16859,222 @@
 </p:sld>
 </file>
 
+<file path=ppt/slides/slide29.xml><?xml version="1.0" encoding="utf-8"?>
+<p:sld xmlns:a="http://schemas.openxmlformats.org/drawingml/2006/main" xmlns:p="http://schemas.openxmlformats.org/presentationml/2006/main" xmlns:r="http://schemas.openxmlformats.org/officeDocument/2006/relationships">
+  <p:cSld>
+    <p:spTree>
+      <p:nvGrpSpPr>
+        <p:cNvPr id="1" name=""/>
+        <p:cNvGrpSpPr/>
+        <p:nvPr/>
+      </p:nvGrpSpPr>
+      <p:grpSpPr/>
+      <p:sp>
+        <p:nvSpPr>
+          <p:cNvPr id="2" name="Rectangle 1"/>
+          <p:cNvSpPr/>
+          <p:nvPr/>
+        </p:nvSpPr>
+        <p:spPr>
+          <a:xfrm>
+            <a:off x="0" y="0"/>
+            <a:ext cx="12191695" cy="6858000"/>
+          </a:xfrm>
+          <a:prstGeom prst="rect">
+            <a:avLst/>
+          </a:prstGeom>
+          <a:solidFill>
+            <a:srgbClr val="0B1C2C"/>
+          </a:solidFill>
+          <a:ln>
+            <a:noFill/>
+          </a:ln>
+        </p:spPr>
+        <p:style>
+          <a:lnRef idx="1">
+            <a:schemeClr val="accent1"/>
+          </a:lnRef>
+          <a:fillRef idx="3">
+            <a:schemeClr val="accent1"/>
+          </a:fillRef>
+          <a:effectRef idx="2">
+            <a:schemeClr val="accent1"/>
+          </a:effectRef>
+          <a:fontRef idx="minor">
+            <a:schemeClr val="lt1"/>
+          </a:fontRef>
+        </p:style>
+        <p:txBody>
+          <a:bodyPr rtlCol="0" anchor="ctr"/>
+          <a:lstStyle/>
+          <a:p>
+            <a:pPr algn="ctr"/>
+          </a:p>
+        </p:txBody>
+      </p:sp>
+      <p:sp>
+        <p:nvSpPr>
+          <p:cNvPr id="3" name="TextBox 2"/>
+          <p:cNvSpPr txBox="1"/>
+          <p:nvPr/>
+        </p:nvSpPr>
+        <p:spPr>
+          <a:xfrm>
+            <a:off x="457200" y="320040"/>
+            <a:ext cx="8229600" cy="640080"/>
+          </a:xfrm>
+          <a:prstGeom prst="rect">
+            <a:avLst/>
+          </a:prstGeom>
+          <a:noFill/>
+        </p:spPr>
+        <p:txBody>
+          <a:bodyPr wrap="none">
+            <a:spAutoFit/>
+          </a:bodyPr>
+          <a:lstStyle/>
+          <a:p>
+            <a:pPr>
+              <a:defRPr sz="2600" b="1">
+                <a:solidFill>
+                  <a:srgbClr val="FFFFFF"/>
+                </a:solidFill>
+                <a:latin typeface="Calibri"/>
+              </a:defRPr>
+            </a:pPr>
+            <a:r>
+              <a:t>July 2026: Four-Sleeve Live Book</a:t>
+            </a:r>
+          </a:p>
+        </p:txBody>
+      </p:sp>
+      <p:sp>
+        <p:nvSpPr>
+          <p:cNvPr id="4" name="TextBox 3"/>
+          <p:cNvSpPr txBox="1"/>
+          <p:nvPr/>
+        </p:nvSpPr>
+        <p:spPr>
+          <a:xfrm>
+            <a:off x="502920" y="1097280"/>
+            <a:ext cx="8229600" cy="5303520"/>
+          </a:xfrm>
+          <a:prstGeom prst="rect">
+            <a:avLst/>
+          </a:prstGeom>
+          <a:noFill/>
+        </p:spPr>
+        <p:txBody>
+          <a:bodyPr wrap="square">
+            <a:spAutoFit/>
+          </a:bodyPr>
+          <a:lstStyle/>
+          <a:p>
+            <a:pPr>
+              <a:spcAft>
+                <a:spcPts val="800"/>
+              </a:spcAft>
+              <a:defRPr sz="1500">
+                <a:solidFill>
+                  <a:srgbClr val="E8EEF4"/>
+                </a:solidFill>
+                <a:latin typeface="Calibri"/>
+              </a:defRPr>
+            </a:pPr>
+            <a:r>
+              <a:t>Cut from ~9 live sleeves → 4 active books (ops + alpha focus)</a:t>
+            </a:r>
+          </a:p>
+          <a:p>
+            <a:pPr>
+              <a:spcAft>
+                <a:spcPts val="800"/>
+              </a:spcAft>
+              <a:defRPr sz="1500">
+                <a:solidFill>
+                  <a:srgbClr val="E8EEF4"/>
+                </a:solidFill>
+                <a:latin typeface="Calibri"/>
+              </a:defRPr>
+            </a:pPr>
+            <a:r>
+              <a:t>ACTIVE: Innovation Fund · Momentum Growth · AI Defense · LLM-Commando</a:t>
+            </a:r>
+          </a:p>
+          <a:p>
+            <a:pPr>
+              <a:spcAft>
+                <a:spcPts val="800"/>
+              </a:spcAft>
+              <a:defRPr sz="1500">
+                <a:solidFill>
+                  <a:srgbClr val="E8EEF4"/>
+                </a:solidFill>
+                <a:latin typeface="Calibri"/>
+              </a:defRPr>
+            </a:pPr>
+            <a:r>
+              <a:t>INACTIVE (history retained in SQLite): Value, Growth Value, Income, Nuclear, LLM-ETF Focus</a:t>
+            </a:r>
+          </a:p>
+          <a:p>
+            <a:pPr>
+              <a:spcAft>
+                <a:spcPts val="800"/>
+              </a:spcAft>
+              <a:defRPr sz="1500">
+                <a:solidFill>
+                  <a:srgbClr val="E8EEF4"/>
+                </a:solidFill>
+                <a:latin typeface="Calibri"/>
+              </a:defRPr>
+            </a:pPr>
+            <a:r>
+              <a:t>Killed books flattened at close where possible; DB deactivates is_active=0</a:t>
+            </a:r>
+          </a:p>
+          <a:p>
+            <a:pPr>
+              <a:spcAft>
+                <a:spcPts val="800"/>
+              </a:spcAft>
+              <a:defRPr sz="1500">
+                <a:solidFill>
+                  <a:srgbClr val="E8EEF4"/>
+                </a:solidFill>
+                <a:latin typeface="Calibri"/>
+              </a:defRPr>
+            </a:pPr>
+            <a:r>
+              <a:t>Dashboard / performance charts: is_active=1 only</a:t>
+            </a:r>
+          </a:p>
+          <a:p>
+            <a:pPr>
+              <a:spcAft>
+                <a:spcPts val="800"/>
+              </a:spcAft>
+              <a:defRPr sz="1500">
+                <a:solidFill>
+                  <a:srgbClr val="E8EEF4"/>
+                </a:solidFill>
+                <a:latin typeface="Calibri"/>
+              </a:defRPr>
+            </a:pPr>
+            <a:r>
+              <a:t>Goal: less labor, clearer attribution, one real LLM stock experiment</a:t>
+            </a:r>
+          </a:p>
+        </p:txBody>
+      </p:sp>
+    </p:spTree>
+  </p:cSld>
+  <p:clrMapOvr>
+    <a:masterClrMapping/>
+  </p:clrMapOvr>
+</p:sld>
+</file>
+
 <file path=ppt/slides/slide3.xml><?xml version="1.0" encoding="utf-8"?>
 <p:sld xmlns:a="http://schemas.openxmlformats.org/drawingml/2006/main" xmlns:p="http://schemas.openxmlformats.org/presentationml/2006/main" xmlns:r="http://schemas.openxmlformats.org/officeDocument/2006/relationships">
   <p:cSld>
@@ -17556,6 +17776,718 @@
             <a:br/>
             <a:r>
               <a:t>for synthesis and conversation.</a:t>
+            </a:r>
+          </a:p>
+        </p:txBody>
+      </p:sp>
+    </p:spTree>
+  </p:cSld>
+  <p:clrMapOvr>
+    <a:masterClrMapping/>
+  </p:clrMapOvr>
+</p:sld>
+</file>
+
+<file path=ppt/slides/slide30.xml><?xml version="1.0" encoding="utf-8"?>
+<p:sld xmlns:a="http://schemas.openxmlformats.org/drawingml/2006/main" xmlns:p="http://schemas.openxmlformats.org/presentationml/2006/main" xmlns:r="http://schemas.openxmlformats.org/officeDocument/2006/relationships">
+  <p:cSld>
+    <p:spTree>
+      <p:nvGrpSpPr>
+        <p:cNvPr id="1" name=""/>
+        <p:cNvGrpSpPr/>
+        <p:nvPr/>
+      </p:nvGrpSpPr>
+      <p:grpSpPr/>
+      <p:sp>
+        <p:nvSpPr>
+          <p:cNvPr id="2" name="Rectangle 1"/>
+          <p:cNvSpPr/>
+          <p:nvPr/>
+        </p:nvSpPr>
+        <p:spPr>
+          <a:xfrm>
+            <a:off x="0" y="0"/>
+            <a:ext cx="12191695" cy="6858000"/>
+          </a:xfrm>
+          <a:prstGeom prst="rect">
+            <a:avLst/>
+          </a:prstGeom>
+          <a:solidFill>
+            <a:srgbClr val="0B1C2C"/>
+          </a:solidFill>
+          <a:ln>
+            <a:noFill/>
+          </a:ln>
+        </p:spPr>
+        <p:style>
+          <a:lnRef idx="1">
+            <a:schemeClr val="accent1"/>
+          </a:lnRef>
+          <a:fillRef idx="3">
+            <a:schemeClr val="accent1"/>
+          </a:fillRef>
+          <a:effectRef idx="2">
+            <a:schemeClr val="accent1"/>
+          </a:effectRef>
+          <a:fontRef idx="minor">
+            <a:schemeClr val="lt1"/>
+          </a:fontRef>
+        </p:style>
+        <p:txBody>
+          <a:bodyPr rtlCol="0" anchor="ctr"/>
+          <a:lstStyle/>
+          <a:p>
+            <a:pPr algn="ctr"/>
+          </a:p>
+        </p:txBody>
+      </p:sp>
+      <p:sp>
+        <p:nvSpPr>
+          <p:cNvPr id="3" name="TextBox 2"/>
+          <p:cNvSpPr txBox="1"/>
+          <p:nvPr/>
+        </p:nvSpPr>
+        <p:spPr>
+          <a:xfrm>
+            <a:off x="457200" y="320040"/>
+            <a:ext cx="8229600" cy="640080"/>
+          </a:xfrm>
+          <a:prstGeom prst="rect">
+            <a:avLst/>
+          </a:prstGeom>
+          <a:noFill/>
+        </p:spPr>
+        <p:txBody>
+          <a:bodyPr wrap="none">
+            <a:spAutoFit/>
+          </a:bodyPr>
+          <a:lstStyle/>
+          <a:p>
+            <a:pPr>
+              <a:defRPr sz="2600" b="1">
+                <a:solidFill>
+                  <a:srgbClr val="FFFFFF"/>
+                </a:solidFill>
+                <a:latin typeface="Calibri"/>
+              </a:defRPr>
+            </a:pPr>
+            <a:r>
+              <a:t>Commando Event Radar + price_is_news</a:t>
+            </a:r>
+          </a:p>
+        </p:txBody>
+      </p:sp>
+      <p:sp>
+        <p:nvSpPr>
+          <p:cNvPr id="4" name="TextBox 3"/>
+          <p:cNvSpPr txBox="1"/>
+          <p:nvPr/>
+        </p:nvSpPr>
+        <p:spPr>
+          <a:xfrm>
+            <a:off x="502920" y="1097280"/>
+            <a:ext cx="8229600" cy="5303520"/>
+          </a:xfrm>
+          <a:prstGeom prst="rect">
+            <a:avLst/>
+          </a:prstGeom>
+          <a:noFill/>
+        </p:spPr>
+        <p:txBody>
+          <a:bodyPr wrap="square">
+            <a:spAutoFit/>
+          </a:bodyPr>
+          <a:lstStyle/>
+          <a:p>
+            <a:pPr>
+              <a:spcAft>
+                <a:spcPts val="800"/>
+              </a:spcAft>
+              <a:defRPr sz="1500">
+                <a:solidFill>
+                  <a:srgbClr val="E8EEF4"/>
+                </a:solidFill>
+                <a:latin typeface="Calibri"/>
+              </a:defRPr>
+            </a:pPr>
+            <a:r>
+              <a:t>llm_comando_radar.py every 2 min RTH — act on NEW news without waiting for clock sessions</a:t>
+            </a:r>
+          </a:p>
+          <a:p>
+            <a:pPr>
+              <a:spcAft>
+                <a:spcPts val="800"/>
+              </a:spcAft>
+              <a:defRPr sz="1500">
+                <a:solidFill>
+                  <a:srgbClr val="E8EEF4"/>
+                </a:solidFill>
+                <a:latin typeface="Calibri"/>
+              </a:defRPr>
+            </a:pPr>
+            <a:r>
+              <a:t>Cheap Sonnet GO path; full Bull→Bear→Judge still at 09:00 / 11:30 / 14:30 CT</a:t>
+            </a:r>
+          </a:p>
+          <a:p>
+            <a:pPr>
+              <a:spcAft>
+                <a:spcPts val="800"/>
+              </a:spcAft>
+              <a:defRPr sz="1500">
+                <a:solidFill>
+                  <a:srgbClr val="E8EEF4"/>
+                </a:solidFill>
+                <a:latin typeface="Calibri"/>
+              </a:defRPr>
+            </a:pPr>
+            <a:r>
+              <a:t>Fire budget: up to 100 event LLM calls/day (~$0.02–0.03 each)</a:t>
+            </a:r>
+          </a:p>
+          <a:p>
+            <a:pPr>
+              <a:spcAft>
+                <a:spcPts val="800"/>
+              </a:spcAft>
+              <a:defRPr sz="1500">
+                <a:solidFill>
+                  <a:srgbClr val="E8EEF4"/>
+                </a:solidFill>
+                <a:latin typeface="Calibri"/>
+              </a:defRPr>
+            </a:pPr>
+            <a:r>
+              <a:t>price_is_news: multi-day loss with no headline IS the event</a:t>
+            </a:r>
+          </a:p>
+          <a:p>
+            <a:pPr>
+              <a:spcAft>
+                <a:spcPts val="800"/>
+              </a:spcAft>
+              <a:defRPr sz="1500">
+                <a:solidFill>
+                  <a:srgbClr val="E8EEF4"/>
+                </a:solidFill>
+                <a:latin typeface="Calibri"/>
+              </a:defRPr>
+            </a:pPr>
+            <a:r>
+              <a:t>  • Trip only if market (SPY) and sector session are NOT down</a:t>
+            </a:r>
+          </a:p>
+          <a:p>
+            <a:pPr>
+              <a:spcAft>
+                <a:spcPts val="800"/>
+              </a:spcAft>
+              <a:defRPr sz="1500">
+                <a:solidFill>
+                  <a:srgbClr val="E8EEF4"/>
+                </a:solidFill>
+                <a:latin typeface="Calibri"/>
+              </a:defRPr>
+            </a:pPr>
+            <a:r>
+              <a:t>  • Default action: sell HALF; residual keeps trailing stops</a:t>
+            </a:r>
+          </a:p>
+          <a:p>
+            <a:pPr>
+              <a:spcAft>
+                <a:spcPts val="800"/>
+              </a:spcAft>
+              <a:defRPr sz="1500">
+                <a:solidFill>
+                  <a:srgbClr val="E8EEF4"/>
+                </a:solidFill>
+                <a:latin typeface="Calibri"/>
+              </a:defRPr>
+            </a:pPr>
+            <a:r>
+              <a:t>  • Market/sector weakness alone is never a sell reason</a:t>
+            </a:r>
+          </a:p>
+        </p:txBody>
+      </p:sp>
+    </p:spTree>
+  </p:cSld>
+  <p:clrMapOvr>
+    <a:masterClrMapping/>
+  </p:clrMapOvr>
+</p:sld>
+</file>
+
+<file path=ppt/slides/slide31.xml><?xml version="1.0" encoding="utf-8"?>
+<p:sld xmlns:a="http://schemas.openxmlformats.org/drawingml/2006/main" xmlns:p="http://schemas.openxmlformats.org/presentationml/2006/main" xmlns:r="http://schemas.openxmlformats.org/officeDocument/2006/relationships">
+  <p:cSld>
+    <p:spTree>
+      <p:nvGrpSpPr>
+        <p:cNvPr id="1" name=""/>
+        <p:cNvGrpSpPr/>
+        <p:nvPr/>
+      </p:nvGrpSpPr>
+      <p:grpSpPr/>
+      <p:sp>
+        <p:nvSpPr>
+          <p:cNvPr id="2" name="Rectangle 1"/>
+          <p:cNvSpPr/>
+          <p:nvPr/>
+        </p:nvSpPr>
+        <p:spPr>
+          <a:xfrm>
+            <a:off x="0" y="0"/>
+            <a:ext cx="12191695" cy="6858000"/>
+          </a:xfrm>
+          <a:prstGeom prst="rect">
+            <a:avLst/>
+          </a:prstGeom>
+          <a:solidFill>
+            <a:srgbClr val="0B1C2C"/>
+          </a:solidFill>
+          <a:ln>
+            <a:noFill/>
+          </a:ln>
+        </p:spPr>
+        <p:style>
+          <a:lnRef idx="1">
+            <a:schemeClr val="accent1"/>
+          </a:lnRef>
+          <a:fillRef idx="3">
+            <a:schemeClr val="accent1"/>
+          </a:fillRef>
+          <a:effectRef idx="2">
+            <a:schemeClr val="accent1"/>
+          </a:effectRef>
+          <a:fontRef idx="minor">
+            <a:schemeClr val="lt1"/>
+          </a:fontRef>
+        </p:style>
+        <p:txBody>
+          <a:bodyPr rtlCol="0" anchor="ctr"/>
+          <a:lstStyle/>
+          <a:p>
+            <a:pPr algn="ctr"/>
+          </a:p>
+        </p:txBody>
+      </p:sp>
+      <p:sp>
+        <p:nvSpPr>
+          <p:cNvPr id="3" name="TextBox 2"/>
+          <p:cNvSpPr txBox="1"/>
+          <p:nvPr/>
+        </p:nvSpPr>
+        <p:spPr>
+          <a:xfrm>
+            <a:off x="457200" y="320040"/>
+            <a:ext cx="8229600" cy="640080"/>
+          </a:xfrm>
+          <a:prstGeom prst="rect">
+            <a:avLst/>
+          </a:prstGeom>
+          <a:noFill/>
+        </p:spPr>
+        <p:txBody>
+          <a:bodyPr wrap="none">
+            <a:spAutoFit/>
+          </a:bodyPr>
+          <a:lstStyle/>
+          <a:p>
+            <a:pPr>
+              <a:defRPr sz="2600" b="1">
+                <a:solidFill>
+                  <a:srgbClr val="FFFFFF"/>
+                </a:solidFill>
+                <a:latin typeface="Calibri"/>
+              </a:defRPr>
+            </a:pPr>
+            <a:r>
+              <a:t>Cold Trader Doctrine (not passivity)</a:t>
+            </a:r>
+          </a:p>
+        </p:txBody>
+      </p:sp>
+      <p:sp>
+        <p:nvSpPr>
+          <p:cNvPr id="4" name="TextBox 3"/>
+          <p:cNvSpPr txBox="1"/>
+          <p:nvPr/>
+        </p:nvSpPr>
+        <p:spPr>
+          <a:xfrm>
+            <a:off x="502920" y="1097280"/>
+            <a:ext cx="8229600" cy="5303520"/>
+          </a:xfrm>
+          <a:prstGeom prst="rect">
+            <a:avLst/>
+          </a:prstGeom>
+          <a:noFill/>
+        </p:spPr>
+        <p:txBody>
+          <a:bodyPr wrap="square">
+            <a:spAutoFit/>
+          </a:bodyPr>
+          <a:lstStyle/>
+          <a:p>
+            <a:pPr>
+              <a:spcAft>
+                <a:spcPts val="800"/>
+              </a:spcAft>
+              <a:defRPr sz="1500">
+                <a:solidFill>
+                  <a:srgbClr val="E8EEF4"/>
+                </a:solidFill>
+                <a:latin typeface="Calibri"/>
+              </a:defRPr>
+            </a:pPr>
+            <a:r>
+              <a:t>REAL &gt; THEATER: earnings / formal guidance beat threatened tariffs</a:t>
+            </a:r>
+          </a:p>
+          <a:p>
+            <a:pPr>
+              <a:spcAft>
+                <a:spcPts val="800"/>
+              </a:spcAft>
+              <a:defRPr sz="1500">
+                <a:solidFill>
+                  <a:srgbClr val="E8EEF4"/>
+                </a:solidFill>
+                <a:latin typeface="Calibri"/>
+              </a:defRPr>
+            </a:pPr>
+            <a:r>
+              <a:t>  • Threat (“could impose”, tweets) = noise for veto purposes</a:t>
+            </a:r>
+          </a:p>
+          <a:p>
+            <a:pPr>
+              <a:spcAft>
+                <a:spcPts val="800"/>
+              </a:spcAft>
+              <a:defRPr sz="1500">
+                <a:solidFill>
+                  <a:srgbClr val="E8EEF4"/>
+                </a:solidFill>
+                <a:latin typeface="Calibri"/>
+              </a:defRPr>
+            </a:pPr>
+            <a:r>
+              <a:t>  • Enacted / in-force / company already booking cost = relevant</a:t>
+            </a:r>
+          </a:p>
+          <a:p>
+            <a:pPr>
+              <a:spcAft>
+                <a:spcPts val="800"/>
+              </a:spcAft>
+              <a:defRPr sz="1500">
+                <a:solidFill>
+                  <a:srgbClr val="E8EEF4"/>
+                </a:solidFill>
+                <a:latin typeface="Calibri"/>
+              </a:defRPr>
+            </a:pPr>
+            <a:r>
+              <a:t>NO CHASE: same-session reaction to a live print can still have room</a:t>
+            </a:r>
+          </a:p>
+          <a:p>
+            <a:pPr>
+              <a:spcAft>
+                <a:spcPts val="800"/>
+              </a:spcAft>
+              <a:defRPr sz="1500">
+                <a:solidFill>
+                  <a:srgbClr val="E8EEF4"/>
+                </a:solidFill>
+                <a:latin typeface="Calibri"/>
+              </a:defRPr>
+            </a:pPr>
+            <a:r>
+              <a:t>  • Day-2 rehash after multi-day run with no new fact → stand down</a:t>
+            </a:r>
+          </a:p>
+          <a:p>
+            <a:pPr>
+              <a:spcAft>
+                <a:spcPts val="800"/>
+              </a:spcAft>
+              <a:defRPr sz="1500">
+                <a:solidFill>
+                  <a:srgbClr val="E8EEF4"/>
+                </a:solidFill>
+                <a:latin typeface="Calibri"/>
+              </a:defRPr>
+            </a:pPr>
+            <a:r>
+              <a:t>COLD EDGE: remove human FOMO &amp; threat-fear — not “trade less”</a:t>
+            </a:r>
+          </a:p>
+          <a:p>
+            <a:pPr>
+              <a:spcAft>
+                <a:spcPts val="800"/>
+              </a:spcAft>
+              <a:defRPr sz="1500">
+                <a:solidFill>
+                  <a:srgbClr val="E8EEF4"/>
+                </a:solidFill>
+                <a:latin typeface="Calibri"/>
+              </a:defRPr>
+            </a:pPr>
+            <a:r>
+              <a:t>  • Selective aggression; exploit crowded late buyers and freeze on real prints</a:t>
+            </a:r>
+          </a:p>
+          <a:p>
+            <a:pPr>
+              <a:spcAft>
+                <a:spcPts val="800"/>
+              </a:spcAft>
+              <a:defRPr sz="1500">
+                <a:solidFill>
+                  <a:srgbClr val="E8EEF4"/>
+                </a:solidFill>
+                <a:latin typeface="Calibri"/>
+              </a:defRPr>
+            </a:pPr>
+            <a:r>
+              <a:t>Lessons 5–6 in llm_lessons.py every dialectic cycle</a:t>
+            </a:r>
+          </a:p>
+        </p:txBody>
+      </p:sp>
+    </p:spTree>
+  </p:cSld>
+  <p:clrMapOvr>
+    <a:masterClrMapping/>
+  </p:clrMapOvr>
+</p:sld>
+</file>
+
+<file path=ppt/slides/slide32.xml><?xml version="1.0" encoding="utf-8"?>
+<p:sld xmlns:a="http://schemas.openxmlformats.org/drawingml/2006/main" xmlns:p="http://schemas.openxmlformats.org/presentationml/2006/main" xmlns:r="http://schemas.openxmlformats.org/officeDocument/2006/relationships">
+  <p:cSld>
+    <p:spTree>
+      <p:nvGrpSpPr>
+        <p:cNvPr id="1" name=""/>
+        <p:cNvGrpSpPr/>
+        <p:nvPr/>
+      </p:nvGrpSpPr>
+      <p:grpSpPr/>
+      <p:sp>
+        <p:nvSpPr>
+          <p:cNvPr id="2" name="Rectangle 1"/>
+          <p:cNvSpPr/>
+          <p:nvPr/>
+        </p:nvSpPr>
+        <p:spPr>
+          <a:xfrm>
+            <a:off x="0" y="0"/>
+            <a:ext cx="12191695" cy="6858000"/>
+          </a:xfrm>
+          <a:prstGeom prst="rect">
+            <a:avLst/>
+          </a:prstGeom>
+          <a:solidFill>
+            <a:srgbClr val="0B1C2C"/>
+          </a:solidFill>
+          <a:ln>
+            <a:noFill/>
+          </a:ln>
+        </p:spPr>
+        <p:style>
+          <a:lnRef idx="1">
+            <a:schemeClr val="accent1"/>
+          </a:lnRef>
+          <a:fillRef idx="3">
+            <a:schemeClr val="accent1"/>
+          </a:fillRef>
+          <a:effectRef idx="2">
+            <a:schemeClr val="accent1"/>
+          </a:effectRef>
+          <a:fontRef idx="minor">
+            <a:schemeClr val="lt1"/>
+          </a:fontRef>
+        </p:style>
+        <p:txBody>
+          <a:bodyPr rtlCol="0" anchor="ctr"/>
+          <a:lstStyle/>
+          <a:p>
+            <a:pPr algn="ctr"/>
+          </a:p>
+        </p:txBody>
+      </p:sp>
+      <p:sp>
+        <p:nvSpPr>
+          <p:cNvPr id="3" name="TextBox 2"/>
+          <p:cNvSpPr txBox="1"/>
+          <p:nvPr/>
+        </p:nvSpPr>
+        <p:spPr>
+          <a:xfrm>
+            <a:off x="457200" y="320040"/>
+            <a:ext cx="8229600" cy="640080"/>
+          </a:xfrm>
+          <a:prstGeom prst="rect">
+            <a:avLst/>
+          </a:prstGeom>
+          <a:noFill/>
+        </p:spPr>
+        <p:txBody>
+          <a:bodyPr wrap="none">
+            <a:spAutoFit/>
+          </a:bodyPr>
+          <a:lstStyle/>
+          <a:p>
+            <a:pPr>
+              <a:defRPr sz="2600" b="1">
+                <a:solidFill>
+                  <a:srgbClr val="FFFFFF"/>
+                </a:solidFill>
+                <a:latin typeface="Calibri"/>
+              </a:defRPr>
+            </a:pPr>
+            <a:r>
+              <a:t>Alpaca Sync Guard (active books)</a:t>
+            </a:r>
+          </a:p>
+        </p:txBody>
+      </p:sp>
+      <p:sp>
+        <p:nvSpPr>
+          <p:cNvPr id="4" name="TextBox 3"/>
+          <p:cNvSpPr txBox="1"/>
+          <p:nvPr/>
+        </p:nvSpPr>
+        <p:spPr>
+          <a:xfrm>
+            <a:off x="502920" y="1097280"/>
+            <a:ext cx="8229600" cy="5303520"/>
+          </a:xfrm>
+          <a:prstGeom prst="rect">
+            <a:avLst/>
+          </a:prstGeom>
+          <a:noFill/>
+        </p:spPr>
+        <p:txBody>
+          <a:bodyPr wrap="square">
+            <a:spAutoFit/>
+          </a:bodyPr>
+          <a:lstStyle/>
+          <a:p>
+            <a:pPr>
+              <a:spcAft>
+                <a:spcPts val="800"/>
+              </a:spcAft>
+              <a:defRPr sz="1500">
+                <a:solidFill>
+                  <a:srgbClr val="E8EEF4"/>
+                </a:solidFill>
+                <a:latin typeface="Calibri"/>
+              </a:defRPr>
+            </a:pPr>
+            <a:r>
+              <a:t>verify_account_synced() before every execute path</a:t>
+            </a:r>
+          </a:p>
+          <a:p>
+            <a:pPr>
+              <a:spcAft>
+                <a:spcPts val="800"/>
+              </a:spcAft>
+              <a:defRPr sz="1500">
+                <a:solidFill>
+                  <a:srgbClr val="E8EEF4"/>
+                </a:solidFill>
+                <a:latin typeface="Calibri"/>
+              </a:defRPr>
+            </a:pPr>
+            <a:r>
+              <a:t>Scope: ACTIVE portfolios only (inactive ghosts no longer trip global halt)</a:t>
+            </a:r>
+          </a:p>
+          <a:p>
+            <a:pPr>
+              <a:spcAft>
+                <a:spcPts val="800"/>
+              </a:spcAft>
+              <a:defRPr sz="1500">
+                <a:solidFill>
+                  <a:srgbClr val="E8EEF4"/>
+                </a:solidFill>
+                <a:latin typeface="Calibri"/>
+              </a:defRPr>
+            </a:pPr>
+            <a:r>
+              <a:t>Halt on: unexpected shorts OR many active-DB names missing at Alpaca</a:t>
+            </a:r>
+          </a:p>
+          <a:p>
+            <a:pPr>
+              <a:spcAft>
+                <a:spcPts val="800"/>
+              </a:spcAft>
+              <a:defRPr sz="1500">
+                <a:solidFill>
+                  <a:srgbClr val="E8EEF4"/>
+                </a:solidFill>
+                <a:latin typeface="Calibri"/>
+              </a:defRPr>
+            </a:pPr>
+            <a:r>
+              <a:t>Self-heal: any path clears stale ALPACA_MISMATCH.flag when clean</a:t>
+            </a:r>
+          </a:p>
+          <a:p>
+            <a:pPr>
+              <a:spcAft>
+                <a:spcPts val="800"/>
+              </a:spcAft>
+              <a:defRPr sz="1500">
+                <a:solidFill>
+                  <a:srgbClr val="E8EEF4"/>
+                </a:solidFill>
+                <a:latin typeface="Calibri"/>
+              </a:defRPr>
+            </a:pPr>
+            <a:r>
+              <a:t>Post-trade re-check on Commando fills (post_trade_verify_or_flag)</a:t>
+            </a:r>
+          </a:p>
+          <a:p>
+            <a:pPr>
+              <a:spcAft>
+                <a:spcPts val="800"/>
+              </a:spcAft>
+              <a:defRPr sz="1500">
+                <a:solidFill>
+                  <a:srgbClr val="E8EEF4"/>
+                </a:solidFill>
+                <a:latin typeface="Calibri"/>
+              </a:defRPr>
+            </a:pPr>
+            <a:r>
+              <a:t>Alpaca orphans (e.g. inactive CPRX left on paper) = WARN only, not freeze</a:t>
+            </a:r>
+          </a:p>
+          <a:p>
+            <a:pPr>
+              <a:spcAft>
+                <a:spcPts val="800"/>
+              </a:spcAft>
+              <a:defRPr sz="1500">
+                <a:solidFill>
+                  <a:srgbClr val="E8EEF4"/>
+                </a:solidFill>
+                <a:latin typeface="Calibri"/>
+              </a:defRPr>
+            </a:pPr>
+            <a:r>
+              <a:t>Flag path: ~/bigclaw-ai/logs/ALPACA_MISMATCH.flag only</a:t>
             </a:r>
           </a:p>
         </p:txBody>
@@ -21346,7 +22278,7 @@
               </a:defRPr>
             </a:pPr>
             <a:r>
-              <a:t>The 7 Portfolios &amp; Style Fidelity</a:t>
+              <a:t>The 4 Live Portfolios &amp; Style Fidelity</a:t>
             </a:r>
           </a:p>
         </p:txBody>
@@ -22308,7 +23240,11 @@
               </a:defRPr>
             </a:pPr>
             <a:r>
-              <a:t>Rules (never relaxed):</a:t>
+              <a:t>LIVE (July 2026 four-sleeve cutover):
+  Innovation Fund · Momentum Growth · AI Defense · LLM-Commando
+INACTIVE (DB history kept): Value, Growth Value, Income, Nuclear, LLM-ETF Focus
+Rules (rule books, never relaxed): max 10 holdings, min 7, max 20% single name
+Style fidelity: each rule book has its own weights/gates — not generic momentum</a:t>
             </a:r>
           </a:p>
         </p:txBody>
@@ -22347,7 +23283,11 @@
                 </a:solidFill>
                 <a:latin typeface="Calibri"/>
               </a:rPr>
-              <a:t>  &gt;  </a:t>
+              <a:t>LIVE (July 2026 four-sleeve cutover):
+  Innovation Fund · Momentum Growth · AI Defense · LLM-Commando
+INACTIVE (DB history kept): Value, Growth Value, Income, Nuclear, LLM-ETF Focus
+Rules (rule books, never relaxed): max 10 holdings, min 7, max 20% single name
+Style fidelity: each rule book has its own weights/gates — not generic momentum</a:t>
             </a:r>
             <a:r>
               <a:rPr sz="1300" b="0">
@@ -22356,7 +23296,7 @@
                 </a:solidFill>
                 <a:latin typeface="Calibri"/>
               </a:rPr>
-              <a:t>Max </a:t>
+              <a:t/>
             </a:r>
             <a:r>
               <a:rPr sz="1300" b="1">
@@ -22365,7 +23305,7 @@
                 </a:solidFill>
                 <a:latin typeface="Calibri"/>
               </a:rPr>
-              <a:t>10 holdings</a:t>
+              <a:t/>
             </a:r>
             <a:r>
               <a:rPr sz="1300" b="0">
@@ -22374,7 +23314,7 @@
                 </a:solidFill>
                 <a:latin typeface="Calibri"/>
               </a:rPr>
-              <a:t>, min </a:t>
+              <a:t/>
             </a:r>
             <a:r>
               <a:rPr sz="1300" b="1">
@@ -22383,7 +23323,7 @@
                 </a:solidFill>
                 <a:latin typeface="Calibri"/>
               </a:rPr>
-              <a:t>7</a:t>
+              <a:t/>
             </a:r>
           </a:p>
           <a:p>
@@ -22399,7 +23339,7 @@
                 </a:solidFill>
                 <a:latin typeface="Calibri"/>
               </a:rPr>
-              <a:t>  &gt;  </a:t>
+              <a:t/>
             </a:r>
             <a:r>
               <a:rPr sz="1300" b="0">
@@ -22408,7 +23348,7 @@
                 </a:solidFill>
                 <a:latin typeface="Calibri"/>
               </a:rPr>
-              <a:t>Max </a:t>
+              <a:t/>
             </a:r>
             <a:r>
               <a:rPr sz="1300" b="1">
@@ -22417,7 +23357,7 @@
                 </a:solidFill>
                 <a:latin typeface="Calibri"/>
               </a:rPr>
-              <a:t>20%</a:t>
+              <a:t/>
             </a:r>
             <a:r>
               <a:rPr sz="1300" b="0">
@@ -22426,7 +23366,7 @@
                 </a:solidFill>
                 <a:latin typeface="Calibri"/>
               </a:rPr>
-              <a:t> in any single position</a:t>
+              <a:t/>
             </a:r>
           </a:p>
           <a:p>
@@ -22442,7 +23382,7 @@
                 </a:solidFill>
                 <a:latin typeface="Calibri"/>
               </a:rPr>
-              <a:t>  &gt;  </a:t>
+              <a:t/>
             </a:r>
             <a:r>
               <a:rPr sz="1300">
@@ -22451,7 +23391,7 @@
                 </a:solidFill>
                 <a:latin typeface="Calibri"/>
               </a:rPr>
-              <a:t>Monthly auto-rebalance (first trading day)</a:t>
+              <a:t/>
             </a:r>
           </a:p>
         </p:txBody>
@@ -22619,7 +23559,7 @@
                   <a:srgbClr val="F0B90B"/>
                 </a:solidFill>
               </a:rPr>
-              <a:t>The 8th Portfolio — LLM-ETF Focus (Experimental)</a:t>
+              <a:t>The 8th Portfolio — LLM-ETF Focus (INACTIVE (July 2026 cutover))</a:t>
             </a:r>
           </a:p>
         </p:txBody>
@@ -22645,7 +23585,7 @@
                   <a:srgbClr val="E8EDF5"/>
                 </a:solidFill>
               </a:rPr>
-              <a:t>Added June 2026 as a controlled experiment — no rule-based engine, no style gates. Observed: ETF-tilted sector rotation.</a:t>
+              <a:t>Added June 2026 · deactivated July 2026 four-sleeve cutover as a controlled experiment — no rule-based engine, no style gates. Observed: ETF-tilted sector rotation.</a:t>
             </a:r>
           </a:p>
           <a:p>
@@ -22744,7 +23684,7 @@
                   <a:srgbClr val="E8EDF5"/>
                 </a:solidFill>
               </a:rPr>
-              <a:t>Experimental purpose: Does LLM judgment with structured self-feedback beat hand-coded rules and SPY?</a:t>
+              <a:t>INACTIVE (July 2026 cutover) purpose: Does LLM judgment with structured self-feedback beat hand-coded rules and SPY?</a:t>
             </a:r>
           </a:p>
         </p:txBody>

</xml_diff>